<commit_message>
removed gemini key fron .env file
</commit_message>
<xml_diff>
--- a/slide_presentation.pptx
+++ b/slide_presentation.pptx
@@ -7544,7 +7544,7 @@
           <a:p>
             <a:fld id="{F223FF85-4E34-4546-B772-76DFA4A6051B}" type="datetimeFigureOut">
               <a:rPr lang="en-US" smtClean="0"/>
-              <a:t>7/14/2026</a:t>
+              <a:t>7/21/2026</a:t>
             </a:fld>
             <a:endParaRPr lang="en-US"/>
           </a:p>
@@ -7721,7 +7721,7 @@
           <a:p>
             <a:fld id="{1B5CC398-6116-4BD2-9FAD-9822FDA158BE}" type="datetimeFigureOut">
               <a:rPr lang="en-US" smtClean="0"/>
-              <a:t>7/14/2026</a:t>
+              <a:t>7/21/2026</a:t>
             </a:fld>
             <a:endParaRPr lang="en-US"/>
           </a:p>
@@ -9412,7 +9412,7 @@
           <a:p>
             <a:fld id="{E5F44E88-89D9-49CC-9E37-1AF77A031198}" type="datetime1">
               <a:rPr lang="en-US" smtClean="0"/>
-              <a:t>7/14/2026</a:t>
+              <a:t>7/21/2026</a:t>
             </a:fld>
             <a:endParaRPr lang="en-US"/>
           </a:p>
@@ -10133,7 +10133,7 @@
           <a:p>
             <a:fld id="{B2188889-44B4-42BD-84DC-2D1A93FD44C7}" type="datetime1">
               <a:rPr lang="en-US" smtClean="0"/>
-              <a:t>7/14/2026</a:t>
+              <a:t>7/21/2026</a:t>
             </a:fld>
             <a:endParaRPr lang="en-US" dirty="0"/>
           </a:p>
@@ -10678,7 +10678,7 @@
           <a:p>
             <a:fld id="{96A40708-E793-490B-9201-425C8D1F325C}" type="datetime1">
               <a:rPr lang="en-US" smtClean="0"/>
-              <a:t>7/14/2026</a:t>
+              <a:t>7/21/2026</a:t>
             </a:fld>
             <a:endParaRPr lang="en-US"/>
           </a:p>
@@ -11041,7 +11041,7 @@
           <a:p>
             <a:fld id="{C1968991-530B-4F8D-80FE-2192BD2DD5A5}" type="datetime1">
               <a:rPr lang="en-US" smtClean="0"/>
-              <a:t>7/14/2026</a:t>
+              <a:t>7/21/2026</a:t>
             </a:fld>
             <a:endParaRPr lang="en-US"/>
           </a:p>
@@ -11290,7 +11290,7 @@
           <a:p>
             <a:fld id="{C23477E6-5CE8-4544-92C7-AEB7D166FD7D}" type="datetime1">
               <a:rPr lang="en-US" smtClean="0"/>
-              <a:t>7/14/2026</a:t>
+              <a:t>7/21/2026</a:t>
             </a:fld>
             <a:endParaRPr lang="en-US"/>
           </a:p>
@@ -11777,7 +11777,7 @@
           <a:p>
             <a:fld id="{D63EB29E-E91D-4BC9-BE3F-394F6FDC9AC7}" type="datetime1">
               <a:rPr lang="en-US" smtClean="0"/>
-              <a:t>7/14/2026</a:t>
+              <a:t>7/21/2026</a:t>
             </a:fld>
             <a:endParaRPr lang="en-US"/>
           </a:p>
@@ -12510,7 +12510,7 @@
           <a:p>
             <a:fld id="{B6BAD7DA-2107-4637-8C8D-3B775970879B}" type="datetime1">
               <a:rPr lang="en-US" smtClean="0"/>
-              <a:t>7/14/2026</a:t>
+              <a:t>7/21/2026</a:t>
             </a:fld>
             <a:endParaRPr lang="en-US"/>
           </a:p>
@@ -12999,7 +12999,7 @@
           <a:p>
             <a:fld id="{659F5542-E2F9-4DC1-8AB7-8E5D8714BD21}" type="datetime1">
               <a:rPr lang="en-US" smtClean="0"/>
-              <a:t>7/14/2026</a:t>
+              <a:t>7/21/2026</a:t>
             </a:fld>
             <a:endParaRPr lang="en-US"/>
           </a:p>
@@ -13490,7 +13490,7 @@
           <a:p>
             <a:fld id="{4597AFA7-1C4B-4AAF-9FD8-61D1DA4C999A}" type="datetime1">
               <a:rPr lang="en-US" smtClean="0"/>
-              <a:t>7/14/2026</a:t>
+              <a:t>7/21/2026</a:t>
             </a:fld>
             <a:endParaRPr lang="en-US"/>
           </a:p>
@@ -13927,7 +13927,7 @@
           <a:p>
             <a:fld id="{EF5F7DF4-8BE0-4832-9230-78DDDEC4B6DD}" type="datetime1">
               <a:rPr lang="en-US" smtClean="0"/>
-              <a:t>7/14/2026</a:t>
+              <a:t>7/21/2026</a:t>
             </a:fld>
             <a:endParaRPr lang="en-US" dirty="0"/>
           </a:p>
@@ -14232,7 +14232,7 @@
           <a:p>
             <a:fld id="{DD3D21CC-B9C8-49F6-ADE7-6BF4A546A74E}" type="datetime1">
               <a:rPr lang="en-US" smtClean="0"/>
-              <a:t>7/14/2026</a:t>
+              <a:t>7/21/2026</a:t>
             </a:fld>
             <a:endParaRPr lang="en-US" dirty="0"/>
           </a:p>
@@ -14585,7 +14585,7 @@
           <a:p>
             <a:fld id="{1AC2C24E-B95E-481D-968E-0BDCFC72F656}" type="datetime1">
               <a:rPr lang="en-US" smtClean="0"/>
-              <a:t>7/14/2026</a:t>
+              <a:t>7/21/2026</a:t>
             </a:fld>
             <a:endParaRPr lang="en-US"/>
           </a:p>
@@ -14881,7 +14881,7 @@
           <a:p>
             <a:fld id="{40723AE1-14A9-42B1-9F02-B524DA830762}" type="datetime1">
               <a:rPr lang="en-US" smtClean="0"/>
-              <a:t>7/14/2026</a:t>
+              <a:t>7/21/2026</a:t>
             </a:fld>
             <a:endParaRPr lang="en-US" dirty="0"/>
           </a:p>
@@ -15136,7 +15136,7 @@
           <a:p>
             <a:fld id="{C1166B1E-1AFA-4A7F-9646-409FBAA0A887}" type="datetime1">
               <a:rPr lang="en-US" smtClean="0"/>
-              <a:t>7/14/2026</a:t>
+              <a:t>7/21/2026</a:t>
             </a:fld>
             <a:endParaRPr lang="en-US" dirty="0"/>
           </a:p>
@@ -15490,7 +15490,7 @@
           <a:p>
             <a:fld id="{F2240801-1142-4411-9AA3-00BC0B3F40DA}" type="datetime1">
               <a:rPr lang="en-US" smtClean="0"/>
-              <a:t>7/14/2026</a:t>
+              <a:t>7/21/2026</a:t>
             </a:fld>
             <a:endParaRPr lang="en-US"/>
           </a:p>
@@ -15757,7 +15757,7 @@
           <a:p>
             <a:fld id="{7CFA9782-9FBA-47E1-A36A-E75622F7046E}" type="datetime1">
               <a:rPr lang="en-US" smtClean="0"/>
-              <a:t>7/14/2026</a:t>
+              <a:t>7/21/2026</a:t>
             </a:fld>
             <a:endParaRPr lang="en-US"/>
           </a:p>
@@ -16103,7 +16103,7 @@
           <a:p>
             <a:fld id="{AA28231D-ABE1-4859-B037-5D42FA8F4858}" type="datetime1">
               <a:rPr lang="en-US" smtClean="0"/>
-              <a:t>7/14/2026</a:t>
+              <a:t>7/21/2026</a:t>
             </a:fld>
             <a:endParaRPr lang="en-US" dirty="0"/>
           </a:p>
@@ -16362,7 +16362,7 @@
           <a:p>
             <a:fld id="{AAA916C4-9175-479B-9610-7E06A2EDFEE0}" type="datetime1">
               <a:rPr lang="en-US" smtClean="0"/>
-              <a:t>7/14/2026</a:t>
+              <a:t>7/21/2026</a:t>
             </a:fld>
             <a:endParaRPr lang="en-US" dirty="0"/>
           </a:p>
@@ -16722,7 +16722,7 @@
           <a:p>
             <a:fld id="{71AD2788-6390-4160-9542-0F1C554F0165}" type="datetime1">
               <a:rPr lang="en-US" smtClean="0"/>
-              <a:t>7/14/2026</a:t>
+              <a:t>7/21/2026</a:t>
             </a:fld>
             <a:endParaRPr lang="en-US" dirty="0"/>
           </a:p>
@@ -16992,7 +16992,7 @@
           <a:p>
             <a:fld id="{C6E6CDFB-328D-4B9A-B955-967B0C6194A8}" type="datetime1">
               <a:rPr lang="en-US" smtClean="0"/>
-              <a:t>7/14/2026</a:t>
+              <a:t>7/21/2026</a:t>
             </a:fld>
             <a:endParaRPr lang="en-US" dirty="0"/>
           </a:p>
@@ -17327,7 +17327,7 @@
           <a:p>
             <a:fld id="{0A994DB4-9653-4FD4-8A14-5DAFB68B0E92}" type="datetime1">
               <a:rPr lang="en-US" smtClean="0"/>
-              <a:t>7/14/2026</a:t>
+              <a:t>7/21/2026</a:t>
             </a:fld>
             <a:endParaRPr lang="en-US"/>
           </a:p>
@@ -17632,7 +17632,7 @@
           <a:p>
             <a:fld id="{0BECFC22-7333-427C-A7BB-2A423772B9A0}" type="datetime1">
               <a:rPr lang="en-US" smtClean="0"/>
-              <a:t>7/14/2026</a:t>
+              <a:t>7/21/2026</a:t>
             </a:fld>
             <a:endParaRPr lang="en-US"/>
           </a:p>
@@ -18088,7 +18088,7 @@
           <a:p>
             <a:fld id="{B78D85C6-8657-43F4-BE68-8F80962A5435}" type="datetime1">
               <a:rPr lang="en-US" smtClean="0"/>
-              <a:t>7/14/2026</a:t>
+              <a:t>7/21/2026</a:t>
             </a:fld>
             <a:endParaRPr lang="en-US"/>
           </a:p>
@@ -18480,7 +18480,7 @@
           <a:p>
             <a:fld id="{59D65A6B-59CD-4A95-97A1-5003425BCE52}" type="datetime1">
               <a:rPr lang="en-US" smtClean="0"/>
-              <a:t>7/14/2026</a:t>
+              <a:t>7/21/2026</a:t>
             </a:fld>
             <a:endParaRPr lang="en-US" dirty="0"/>
           </a:p>
@@ -18820,7 +18820,7 @@
           <a:p>
             <a:fld id="{AEBE612C-E459-4252-B286-C98BDF4C5E92}" type="datetime1">
               <a:rPr lang="en-US" smtClean="0"/>
-              <a:t>7/14/2026</a:t>
+              <a:t>7/21/2026</a:t>
             </a:fld>
             <a:endParaRPr lang="en-US" dirty="0"/>
           </a:p>
@@ -19158,7 +19158,7 @@
           <a:p>
             <a:fld id="{D8568ADA-B78D-4076-A9DF-6C8E04B71243}" type="datetime1">
               <a:rPr lang="en-US" smtClean="0"/>
-              <a:t>7/14/2026</a:t>
+              <a:t>7/21/2026</a:t>
             </a:fld>
             <a:endParaRPr lang="en-US"/>
           </a:p>
@@ -19447,7 +19447,7 @@
           <a:p>
             <a:fld id="{E3ED234F-BBE0-48A3-AC31-D10A1F3BC187}" type="datetime1">
               <a:rPr lang="en-US" smtClean="0"/>
-              <a:t>7/14/2026</a:t>
+              <a:t>7/21/2026</a:t>
             </a:fld>
             <a:endParaRPr lang="en-US"/>
           </a:p>
@@ -19731,7 +19731,7 @@
           <a:p>
             <a:fld id="{AA0D3809-2B53-482D-AD1B-8B09C4B2656C}" type="datetime1">
               <a:rPr lang="en-US" smtClean="0"/>
-              <a:t>7/14/2026</a:t>
+              <a:t>7/21/2026</a:t>
             </a:fld>
             <a:endParaRPr lang="en-US"/>
           </a:p>
@@ -20215,7 +20215,7 @@
           <a:p>
             <a:fld id="{154F04C1-B149-48D4-90B8-E64820B32F59}" type="datetime1">
               <a:rPr lang="en-US" smtClean="0"/>
-              <a:t>7/14/2026</a:t>
+              <a:t>7/21/2026</a:t>
             </a:fld>
             <a:endParaRPr lang="en-US"/>
           </a:p>
@@ -20704,7 +20704,7 @@
           <a:p>
             <a:fld id="{81AED7B4-8DB4-40B0-90CF-49D3708442C0}" type="datetime1">
               <a:rPr lang="en-US" smtClean="0"/>
-              <a:t>7/14/2026</a:t>
+              <a:t>7/21/2026</a:t>
             </a:fld>
             <a:endParaRPr lang="en-US"/>
           </a:p>
@@ -20934,7 +20934,7 @@
           <a:p>
             <a:fld id="{F861E720-2EA4-4832-8DC2-DC3D2BDBB07C}" type="datetime1">
               <a:rPr lang="en-US" smtClean="0"/>
-              <a:t>7/14/2026</a:t>
+              <a:t>7/21/2026</a:t>
             </a:fld>
             <a:endParaRPr lang="en-US"/>
           </a:p>
@@ -21714,7 +21714,7 @@
           <a:p>
             <a:fld id="{AB608D6C-D0F1-479F-911E-8569D2F1ED15}" type="datetime1">
               <a:rPr lang="en-US" smtClean="0"/>
-              <a:t>7/14/2026</a:t>
+              <a:t>7/21/2026</a:t>
             </a:fld>
             <a:endParaRPr lang="en-US"/>
           </a:p>
@@ -22004,7 +22004,7 @@
           <a:p>
             <a:fld id="{83DFFD80-41C6-4EAA-B049-EE90EA550127}" type="datetime1">
               <a:rPr lang="en-US" smtClean="0"/>
-              <a:t>7/14/2026</a:t>
+              <a:t>7/21/2026</a:t>
             </a:fld>
             <a:endParaRPr lang="en-US" dirty="0"/>
           </a:p>
@@ -22607,7 +22607,7 @@
           <a:p>
             <a:fld id="{CBCFCC67-CBC1-48BE-A467-33E284003C9C}" type="datetime1">
               <a:rPr lang="en-US" smtClean="0"/>
-              <a:t>7/14/2026</a:t>
+              <a:t>7/21/2026</a:t>
             </a:fld>
             <a:endParaRPr lang="en-US"/>
           </a:p>
@@ -22805,7 +22805,7 @@
           <a:p>
             <a:fld id="{3BF01E07-9F97-42AE-9FE9-3EAD856BDB2A}" type="datetime1">
               <a:rPr lang="en-US" smtClean="0"/>
-              <a:t>7/14/2026</a:t>
+              <a:t>7/21/2026</a:t>
             </a:fld>
             <a:endParaRPr lang="en-US"/>
           </a:p>
@@ -23554,7 +23554,7 @@
           <a:p>
             <a:fld id="{D34B2334-B27F-4DA0-8A92-599603070D6B}" type="datetime1">
               <a:rPr lang="en-US" smtClean="0"/>
-              <a:t>7/14/2026</a:t>
+              <a:t>7/21/2026</a:t>
             </a:fld>
             <a:endParaRPr lang="en-US"/>
           </a:p>
@@ -24057,7 +24057,7 @@
           <a:p>
             <a:fld id="{D9B8D85F-DE7D-4C09-9BDD-03377313F809}" type="datetime1">
               <a:rPr lang="en-US" smtClean="0"/>
-              <a:t>7/14/2026</a:t>
+              <a:t>7/21/2026</a:t>
             </a:fld>
             <a:endParaRPr lang="en-US"/>
           </a:p>
@@ -24432,7 +24432,7 @@
           <a:p>
             <a:fld id="{68CAF44C-1683-44E3-97C5-DF51C69BF7AA}" type="datetime1">
               <a:rPr lang="en-US" smtClean="0"/>
-              <a:t>7/14/2026</a:t>
+              <a:t>7/21/2026</a:t>
             </a:fld>
             <a:endParaRPr lang="en-US"/>
           </a:p>
@@ -24904,7 +24904,7 @@
           <a:p>
             <a:fld id="{CD150565-788C-402B-B078-3F96B9A231B8}" type="datetime1">
               <a:rPr lang="en-US" smtClean="0"/>
-              <a:t>7/14/2026</a:t>
+              <a:t>7/21/2026</a:t>
             </a:fld>
             <a:endParaRPr lang="en-US"/>
           </a:p>
@@ -25062,7 +25062,7 @@
           <a:p>
             <a:fld id="{D7B20C69-CB4E-44F7-A408-67C55627795C}" type="datetime1">
               <a:rPr lang="en-US" smtClean="0"/>
-              <a:t>7/14/2026</a:t>
+              <a:t>7/21/2026</a:t>
             </a:fld>
             <a:endParaRPr lang="en-US"/>
           </a:p>
@@ -25184,7 +25184,7 @@
           <a:p>
             <a:fld id="{A0C8FE45-F91B-4375-B362-4DC6F9A2A304}" type="datetime1">
               <a:rPr lang="en-US" smtClean="0"/>
-              <a:t>7/14/2026</a:t>
+              <a:t>7/21/2026</a:t>
             </a:fld>
             <a:endParaRPr lang="en-US"/>
           </a:p>
@@ -25500,7 +25500,7 @@
           <a:p>
             <a:fld id="{572A1522-8F1E-408E-ABA2-6F5B206582B8}" type="datetime1">
               <a:rPr lang="en-US" smtClean="0"/>
-              <a:t>7/14/2026</a:t>
+              <a:t>7/21/2026</a:t>
             </a:fld>
             <a:endParaRPr lang="en-US"/>
           </a:p>
@@ -25815,7 +25815,7 @@
           <a:p>
             <a:fld id="{3E19A776-5AE6-4251-8560-C6066D0B46D6}" type="datetime1">
               <a:rPr lang="en-US" smtClean="0"/>
-              <a:t>7/14/2026</a:t>
+              <a:t>7/21/2026</a:t>
             </a:fld>
             <a:endParaRPr lang="en-US"/>
           </a:p>
@@ -26104,7 +26104,7 @@
           <a:p>
             <a:fld id="{44210B3C-79E3-495A-B2C3-EF766F409D04}" type="datetime1">
               <a:rPr lang="en-US" smtClean="0"/>
-              <a:t>7/14/2026</a:t>
+              <a:t>7/21/2026</a:t>
             </a:fld>
             <a:endParaRPr lang="en-US" dirty="0"/>
           </a:p>
@@ -26469,7 +26469,7 @@
           <a:p>
             <a:fld id="{195FFA61-E651-4E50-A159-710A5ED7E6FE}" type="datetime1">
               <a:rPr lang="en-US" smtClean="0"/>
-              <a:t>7/14/2026</a:t>
+              <a:t>7/21/2026</a:t>
             </a:fld>
             <a:endParaRPr lang="en-US"/>
           </a:p>
@@ -26973,7 +26973,7 @@
           <a:p>
             <a:fld id="{8E9E0D87-B7D0-4C2E-BAD1-97A555313A20}" type="datetime1">
               <a:rPr lang="en-US" smtClean="0"/>
-              <a:t>7/14/2026</a:t>
+              <a:t>7/21/2026</a:t>
             </a:fld>
             <a:endParaRPr lang="en-US"/>
           </a:p>
@@ -27208,7 +27208,7 @@
           <a:p>
             <a:fld id="{29814657-813A-4D7B-A2F8-E573BA1645D3}" type="datetime1">
               <a:rPr lang="en-US" smtClean="0"/>
-              <a:t>7/14/2026</a:t>
+              <a:t>7/21/2026</a:t>
             </a:fld>
             <a:endParaRPr lang="en-US" dirty="0"/>
           </a:p>
@@ -27384,7 +27384,7 @@
           <a:p>
             <a:fld id="{29814657-813A-4D7B-A2F8-E573BA1645D3}" type="datetime1">
               <a:rPr lang="en-US" smtClean="0"/>
-              <a:t>7/14/2026</a:t>
+              <a:t>7/21/2026</a:t>
             </a:fld>
             <a:endParaRPr lang="en-US" dirty="0"/>
           </a:p>
@@ -27634,7 +27634,7 @@
           <a:p>
             <a:fld id="{29814657-813A-4D7B-A2F8-E573BA1645D3}" type="datetime1">
               <a:rPr lang="en-US" smtClean="0"/>
-              <a:t>7/14/2026</a:t>
+              <a:t>7/21/2026</a:t>
             </a:fld>
             <a:endParaRPr lang="en-US" dirty="0"/>
           </a:p>
@@ -27876,7 +27876,7 @@
           <a:p>
             <a:fld id="{29814657-813A-4D7B-A2F8-E573BA1645D3}" type="datetime1">
               <a:rPr lang="en-US" smtClean="0"/>
-              <a:t>7/14/2026</a:t>
+              <a:t>7/21/2026</a:t>
             </a:fld>
             <a:endParaRPr lang="en-US" dirty="0"/>
           </a:p>
@@ -28348,7 +28348,7 @@
           <a:p>
             <a:fld id="{29814657-813A-4D7B-A2F8-E573BA1645D3}" type="datetime1">
               <a:rPr lang="en-US" smtClean="0"/>
-              <a:t>7/14/2026</a:t>
+              <a:t>7/21/2026</a:t>
             </a:fld>
             <a:endParaRPr lang="en-US" dirty="0"/>
           </a:p>
@@ -28472,7 +28472,7 @@
           <a:p>
             <a:fld id="{D7B20C69-CB4E-44F7-A408-67C55627795C}" type="datetime1">
               <a:rPr lang="en-US" smtClean="0"/>
-              <a:t>7/14/2026</a:t>
+              <a:t>7/21/2026</a:t>
             </a:fld>
             <a:endParaRPr lang="en-US"/>
           </a:p>
@@ -28570,7 +28570,7 @@
           <a:p>
             <a:fld id="{29814657-813A-4D7B-A2F8-E573BA1645D3}" type="datetime1">
               <a:rPr lang="en-US" smtClean="0"/>
-              <a:t>7/14/2026</a:t>
+              <a:t>7/21/2026</a:t>
             </a:fld>
             <a:endParaRPr lang="en-US" dirty="0"/>
           </a:p>
@@ -28831,7 +28831,7 @@
           <a:p>
             <a:fld id="{572A1522-8F1E-408E-ABA2-6F5B206582B8}" type="datetime1">
               <a:rPr lang="en-US" smtClean="0"/>
-              <a:t>7/14/2026</a:t>
+              <a:t>7/21/2026</a:t>
             </a:fld>
             <a:endParaRPr lang="en-US"/>
           </a:p>
@@ -29133,7 +29133,7 @@
           <a:p>
             <a:fld id="{D6235515-DA3D-4D9A-9B02-44E2CBD9110F}" type="datetime1">
               <a:rPr lang="en-US" smtClean="0"/>
-              <a:t>7/14/2026</a:t>
+              <a:t>7/21/2026</a:t>
             </a:fld>
             <a:endParaRPr lang="en-US" dirty="0"/>
           </a:p>
@@ -29493,7 +29493,7 @@
           <a:p>
             <a:fld id="{3E19A776-5AE6-4251-8560-C6066D0B46D6}" type="datetime1">
               <a:rPr lang="en-US" smtClean="0"/>
-              <a:t>7/14/2026</a:t>
+              <a:t>7/21/2026</a:t>
             </a:fld>
             <a:endParaRPr lang="en-US"/>
           </a:p>
@@ -29794,7 +29794,7 @@
           <a:p>
             <a:fld id="{29814657-813A-4D7B-A2F8-E573BA1645D3}" type="datetime1">
               <a:rPr lang="en-US" smtClean="0"/>
-              <a:t>7/14/2026</a:t>
+              <a:t>7/21/2026</a:t>
             </a:fld>
             <a:endParaRPr lang="en-US" dirty="0"/>
           </a:p>
@@ -29992,7 +29992,7 @@
           <a:p>
             <a:fld id="{29814657-813A-4D7B-A2F8-E573BA1645D3}" type="datetime1">
               <a:rPr lang="en-US" smtClean="0"/>
-              <a:t>7/14/2026</a:t>
+              <a:t>7/21/2026</a:t>
             </a:fld>
             <a:endParaRPr lang="en-US" dirty="0"/>
           </a:p>
@@ -30259,7 +30259,7 @@
           <a:p>
             <a:fld id="{29814657-813A-4D7B-A2F8-E573BA1645D3}" type="datetime1">
               <a:rPr lang="en-US" smtClean="0"/>
-              <a:t>7/14/2026</a:t>
+              <a:t>7/21/2026</a:t>
             </a:fld>
             <a:endParaRPr lang="en-US" dirty="0"/>
           </a:p>
@@ -30689,7 +30689,7 @@
           <a:p>
             <a:fld id="{29814657-813A-4D7B-A2F8-E573BA1645D3}" type="datetime1">
               <a:rPr lang="en-US" smtClean="0"/>
-              <a:t>7/14/2026</a:t>
+              <a:t>7/21/2026</a:t>
             </a:fld>
             <a:endParaRPr lang="en-US" dirty="0"/>
           </a:p>
@@ -31232,7 +31232,7 @@
           <a:p>
             <a:fld id="{29814657-813A-4D7B-A2F8-E573BA1645D3}" type="datetime1">
               <a:rPr lang="en-US" smtClean="0"/>
-              <a:t>7/14/2026</a:t>
+              <a:t>7/21/2026</a:t>
             </a:fld>
             <a:endParaRPr lang="en-US" dirty="0"/>
           </a:p>
@@ -32102,7 +32102,7 @@
           <a:p>
             <a:fld id="{29814657-813A-4D7B-A2F8-E573BA1645D3}" type="datetime1">
               <a:rPr lang="en-US" smtClean="0"/>
-              <a:t>7/14/2026</a:t>
+              <a:t>7/21/2026</a:t>
             </a:fld>
             <a:endParaRPr lang="en-US" dirty="0"/>
           </a:p>
@@ -32278,7 +32278,7 @@
           <a:p>
             <a:fld id="{29814657-813A-4D7B-A2F8-E573BA1645D3}" type="datetime1">
               <a:rPr lang="en-US" smtClean="0"/>
-              <a:t>7/14/2026</a:t>
+              <a:t>7/21/2026</a:t>
             </a:fld>
             <a:endParaRPr lang="en-US" dirty="0"/>
           </a:p>
@@ -32468,7 +32468,7 @@
           <a:p>
             <a:fld id="{29814657-813A-4D7B-A2F8-E573BA1645D3}" type="datetime1">
               <a:rPr lang="en-US" smtClean="0"/>
-              <a:t>7/14/2026</a:t>
+              <a:t>7/21/2026</a:t>
             </a:fld>
             <a:endParaRPr lang="en-US" dirty="0"/>
           </a:p>
@@ -32948,7 +32948,7 @@
           <a:p>
             <a:fld id="{852BD0B2-E7A7-4B81-8BAF-4B92BD6A4310}" type="datetime1">
               <a:rPr lang="en-US" smtClean="0"/>
-              <a:t>7/14/2026</a:t>
+              <a:t>7/21/2026</a:t>
             </a:fld>
             <a:endParaRPr lang="en-US"/>
           </a:p>
@@ -33446,7 +33446,7 @@
           <a:p>
             <a:fld id="{A0E657DB-59AB-47CC-B4C7-A245A3C76BB1}" type="datetime1">
               <a:rPr lang="en-US" smtClean="0"/>
-              <a:t>7/14/2026</a:t>
+              <a:t>7/21/2026</a:t>
             </a:fld>
             <a:endParaRPr lang="en-US"/>
           </a:p>
@@ -33944,7 +33944,7 @@
           <a:p>
             <a:fld id="{1415DC98-F527-4737-A5B9-3597210FA2F7}" type="datetime1">
               <a:rPr lang="en-US" smtClean="0"/>
-              <a:t>7/14/2026</a:t>
+              <a:t>7/21/2026</a:t>
             </a:fld>
             <a:endParaRPr lang="en-US" dirty="0"/>
           </a:p>
@@ -34237,7 +34237,7 @@
           <a:p>
             <a:fld id="{29814657-813A-4D7B-A2F8-E573BA1645D3}" type="datetime1">
               <a:rPr lang="en-US" smtClean="0"/>
-              <a:t>7/14/2026</a:t>
+              <a:t>7/21/2026</a:t>
             </a:fld>
             <a:endParaRPr lang="en-US" dirty="0"/>
           </a:p>
@@ -34836,7 +34836,7 @@
           <a:p>
             <a:fld id="{29814657-813A-4D7B-A2F8-E573BA1645D3}" type="datetime1">
               <a:rPr lang="en-US" smtClean="0"/>
-              <a:t>7/14/2026</a:t>
+              <a:t>7/21/2026</a:t>
             </a:fld>
             <a:endParaRPr lang="en-US" dirty="0"/>
           </a:p>
@@ -35552,14 +35552,18 @@
           <a:p>
             <a:r>
               <a:rPr lang="en-SG" dirty="0"/>
-              <a:t>Interactive ENTERPRISE IT</a:t>
+              <a:t>Interactive</a:t>
             </a:r>
             <a:br>
               <a:rPr lang="en-SG" dirty="0"/>
             </a:br>
             <a:r>
+              <a:rPr lang="en-SG" dirty="0" err="1"/>
+              <a:t>CyberSECURITY</a:t>
+            </a:r>
+            <a:r>
               <a:rPr lang="en-SG" dirty="0"/>
-              <a:t>Cyber Range</a:t>
+              <a:t> Range</a:t>
             </a:r>
           </a:p>
         </p:txBody>
@@ -35810,20 +35814,17 @@
               <a:rPr lang="en-SG" dirty="0">
                 <a:latin typeface="Bahnschrift SemiLight (Body)"/>
               </a:rPr>
-              <a:t>Phases Mapped to </a:t>
+              <a:t>Phases Mapped to National Institute of Standards and Technology (</a:t>
             </a:r>
             <a:r>
               <a:rPr lang="en-US" dirty="0">
                 <a:latin typeface="Bahnschrift SemiLight (Body)"/>
               </a:rPr>
-              <a:t>NIST Cybersecurity Framework (CSF)</a:t>
-            </a:r>
-            <a:r>
-              <a:rPr lang="en-SG" dirty="0">
-                <a:latin typeface="Bahnschrift SemiLight (Body)"/>
-              </a:rPr>
-              <a:t> </a:t>
-            </a:r>
+              <a:t>NIST) Cybersecurity Framework</a:t>
+            </a:r>
+            <a:endParaRPr lang="en-SG" dirty="0">
+              <a:latin typeface="Bahnschrift SemiLight (Body)"/>
+            </a:endParaRPr>
           </a:p>
         </p:txBody>
       </p:sp>
@@ -36151,6 +36152,43 @@
             <a:endParaRPr lang="en-SG" sz="1600" dirty="0">
               <a:latin typeface="Abadi" panose="020F0502020204030204" pitchFamily="34" charset="0"/>
             </a:endParaRPr>
+          </a:p>
+        </p:txBody>
+      </p:sp>
+      <p:sp>
+        <p:nvSpPr>
+          <p:cNvPr id="2" name="TextBox 1">
+            <a:extLst>
+              <a:ext uri="{FF2B5EF4-FFF2-40B4-BE49-F238E27FC236}">
+                <a16:creationId xmlns:a16="http://schemas.microsoft.com/office/drawing/2014/main" id="{DB724075-2185-877E-481F-6DB02267681A}"/>
+              </a:ext>
+            </a:extLst>
+          </p:cNvPr>
+          <p:cNvSpPr txBox="1"/>
+          <p:nvPr/>
+        </p:nvSpPr>
+        <p:spPr>
+          <a:xfrm>
+            <a:off x="7411253" y="6248541"/>
+            <a:ext cx="4138249" cy="338554"/>
+          </a:xfrm>
+          <a:prstGeom prst="rect">
+            <a:avLst/>
+          </a:prstGeom>
+          <a:noFill/>
+        </p:spPr>
+        <p:txBody>
+          <a:bodyPr wrap="none" rtlCol="0">
+            <a:spAutoFit/>
+          </a:bodyPr>
+          <a:lstStyle/>
+          <a:p>
+            <a:r>
+              <a:rPr lang="en-SG" sz="1600" dirty="0">
+                <a:latin typeface="Abadi" panose="020B0604020104020204" pitchFamily="34" charset="0"/>
+              </a:rPr>
+              <a:t>Source: https://www.nist.gov/cyberframework</a:t>
+            </a:r>
           </a:p>
         </p:txBody>
       </p:sp>
@@ -36215,7 +36253,15 @@
           <a:p>
             <a:r>
               <a:rPr lang="en-SG" dirty="0"/>
-              <a:t>Interactive Smart City Cyber Range</a:t>
+              <a:t>Interactive Smart City </a:t>
+            </a:r>
+            <a:r>
+              <a:rPr lang="en-SG" dirty="0" err="1"/>
+              <a:t>CyberSECURITY</a:t>
+            </a:r>
+            <a:r>
+              <a:rPr lang="en-SG" dirty="0"/>
+              <a:t> Range</a:t>
             </a:r>
           </a:p>
         </p:txBody>
@@ -36440,55 +36486,6 @@
           <a:chExt cx="0" cy="0"/>
         </a:xfrm>
       </p:grpSpPr>
-      <p:sp>
-        <p:nvSpPr>
-          <p:cNvPr id="7" name="Title 6">
-            <a:extLst>
-              <a:ext uri="{FF2B5EF4-FFF2-40B4-BE49-F238E27FC236}">
-                <a16:creationId xmlns:a16="http://schemas.microsoft.com/office/drawing/2014/main" id="{802F2E65-D8C2-5883-7150-FE881982AE09}"/>
-              </a:ext>
-            </a:extLst>
-          </p:cNvPr>
-          <p:cNvSpPr>
-            <a:spLocks noGrp="1"/>
-          </p:cNvSpPr>
-          <p:nvPr>
-            <p:ph type="title"/>
-          </p:nvPr>
-        </p:nvSpPr>
-        <p:spPr>
-          <a:xfrm>
-            <a:off x="913795" y="609600"/>
-            <a:ext cx="10353762" cy="970450"/>
-          </a:xfrm>
-        </p:spPr>
-        <p:txBody>
-          <a:bodyPr>
-            <a:normAutofit fontScale="90000"/>
-          </a:bodyPr>
-          <a:lstStyle/>
-          <a:p>
-            <a:r>
-              <a:rPr lang="en-SG" dirty="0">
-                <a:latin typeface="Bahnschrift SemiLight (Body)"/>
-              </a:rPr>
-              <a:t>Phases Mapped to </a:t>
-            </a:r>
-            <a:r>
-              <a:rPr lang="en-US" dirty="0">
-                <a:latin typeface="Bahnschrift SemiLight (Body)"/>
-              </a:rPr>
-              <a:t>NIST Cybersecurity Framework (CSF)</a:t>
-            </a:r>
-            <a:r>
-              <a:rPr lang="en-SG" dirty="0">
-                <a:latin typeface="Bahnschrift SemiLight (Body)"/>
-              </a:rPr>
-              <a:t> </a:t>
-            </a:r>
-          </a:p>
-        </p:txBody>
-      </p:sp>
       <p:graphicFrame>
         <p:nvGraphicFramePr>
           <p:cNvPr id="9" name="Diagram 8">
@@ -36963,6 +36960,184 @@
               <a:latin typeface="Abadi" panose="020F0502020204030204" pitchFamily="34" charset="0"/>
               <a:ea typeface="+mn-ea"/>
               <a:cs typeface="+mn-cs"/>
+            </a:endParaRPr>
+          </a:p>
+        </p:txBody>
+      </p:sp>
+      <p:sp>
+        <p:nvSpPr>
+          <p:cNvPr id="3" name="TextBox 2">
+            <a:extLst>
+              <a:ext uri="{FF2B5EF4-FFF2-40B4-BE49-F238E27FC236}">
+                <a16:creationId xmlns:a16="http://schemas.microsoft.com/office/drawing/2014/main" id="{2A52649F-EC67-403F-27CF-362134EFE6D9}"/>
+              </a:ext>
+            </a:extLst>
+          </p:cNvPr>
+          <p:cNvSpPr txBox="1"/>
+          <p:nvPr/>
+        </p:nvSpPr>
+        <p:spPr>
+          <a:xfrm>
+            <a:off x="7411253" y="6248541"/>
+            <a:ext cx="4138249" cy="338554"/>
+          </a:xfrm>
+          <a:prstGeom prst="rect">
+            <a:avLst/>
+          </a:prstGeom>
+          <a:noFill/>
+        </p:spPr>
+        <p:txBody>
+          <a:bodyPr wrap="none" rtlCol="0">
+            <a:spAutoFit/>
+          </a:bodyPr>
+          <a:lstStyle/>
+          <a:p>
+            <a:r>
+              <a:rPr lang="en-SG" sz="1600" dirty="0">
+                <a:latin typeface="Abadi" panose="020B0604020104020204" pitchFamily="34" charset="0"/>
+              </a:rPr>
+              <a:t>Source: https://www.nist.gov/cyberframework</a:t>
+            </a:r>
+          </a:p>
+        </p:txBody>
+      </p:sp>
+      <p:sp>
+        <p:nvSpPr>
+          <p:cNvPr id="6" name="Title 6">
+            <a:extLst>
+              <a:ext uri="{FF2B5EF4-FFF2-40B4-BE49-F238E27FC236}">
+                <a16:creationId xmlns:a16="http://schemas.microsoft.com/office/drawing/2014/main" id="{E4A539F3-EE00-02F3-FB58-23E9454C1B6D}"/>
+              </a:ext>
+            </a:extLst>
+          </p:cNvPr>
+          <p:cNvSpPr txBox="1">
+            <a:spLocks/>
+          </p:cNvSpPr>
+          <p:nvPr/>
+        </p:nvSpPr>
+        <p:spPr>
+          <a:xfrm>
+            <a:off x="1066195" y="762000"/>
+            <a:ext cx="10353762" cy="970450"/>
+          </a:xfrm>
+          <a:prstGeom prst="rect">
+            <a:avLst/>
+          </a:prstGeom>
+          <a:effectLst>
+            <a:outerShdw blurRad="25400" dir="17880000">
+              <a:srgbClr val="000000">
+                <a:alpha val="46000"/>
+              </a:srgbClr>
+            </a:outerShdw>
+          </a:effectLst>
+        </p:spPr>
+        <p:txBody>
+          <a:bodyPr vert="horz" lIns="91440" tIns="45720" rIns="91440" bIns="45720" rtlCol="0" anchor="ctr">
+            <a:normAutofit fontScale="82500" lnSpcReduction="20000"/>
+          </a:bodyPr>
+          <a:lstStyle>
+            <a:lvl1pPr algn="ctr" defTabSz="457200" rtl="0" eaLnBrk="1" latinLnBrk="0" hangingPunct="1">
+              <a:spcBef>
+                <a:spcPct val="0"/>
+              </a:spcBef>
+              <a:buNone/>
+              <a:defRPr sz="4000" kern="1200">
+                <a:ln>
+                  <a:solidFill>
+                    <a:schemeClr val="bg1">
+                      <a:lumMod val="75000"/>
+                      <a:lumOff val="25000"/>
+                      <a:alpha val="10000"/>
+                    </a:schemeClr>
+                  </a:solidFill>
+                </a:ln>
+                <a:solidFill>
+                  <a:schemeClr val="tx2"/>
+                </a:solidFill>
+                <a:effectLst>
+                  <a:outerShdw blurRad="9525" dist="25400" dir="14640000" algn="tl" rotWithShape="0">
+                    <a:schemeClr val="bg1">
+                      <a:alpha val="30000"/>
+                    </a:schemeClr>
+                  </a:outerShdw>
+                </a:effectLst>
+                <a:latin typeface="+mj-lt"/>
+                <a:ea typeface="+mj-ea"/>
+                <a:cs typeface="Trebuchet MS"/>
+              </a:defRPr>
+            </a:lvl1pPr>
+            <a:lvl2pPr eaLnBrk="1" hangingPunct="1">
+              <a:defRPr>
+                <a:solidFill>
+                  <a:schemeClr val="tx2"/>
+                </a:solidFill>
+              </a:defRPr>
+            </a:lvl2pPr>
+            <a:lvl3pPr eaLnBrk="1" hangingPunct="1">
+              <a:defRPr>
+                <a:solidFill>
+                  <a:schemeClr val="tx2"/>
+                </a:solidFill>
+              </a:defRPr>
+            </a:lvl3pPr>
+            <a:lvl4pPr eaLnBrk="1" hangingPunct="1">
+              <a:defRPr>
+                <a:solidFill>
+                  <a:schemeClr val="tx2"/>
+                </a:solidFill>
+              </a:defRPr>
+            </a:lvl4pPr>
+            <a:lvl5pPr eaLnBrk="1" hangingPunct="1">
+              <a:defRPr>
+                <a:solidFill>
+                  <a:schemeClr val="tx2"/>
+                </a:solidFill>
+              </a:defRPr>
+            </a:lvl5pPr>
+            <a:lvl6pPr eaLnBrk="1" hangingPunct="1">
+              <a:defRPr>
+                <a:solidFill>
+                  <a:schemeClr val="tx2"/>
+                </a:solidFill>
+              </a:defRPr>
+            </a:lvl6pPr>
+            <a:lvl7pPr eaLnBrk="1" hangingPunct="1">
+              <a:defRPr>
+                <a:solidFill>
+                  <a:schemeClr val="tx2"/>
+                </a:solidFill>
+              </a:defRPr>
+            </a:lvl7pPr>
+            <a:lvl8pPr eaLnBrk="1" hangingPunct="1">
+              <a:defRPr>
+                <a:solidFill>
+                  <a:schemeClr val="tx2"/>
+                </a:solidFill>
+              </a:defRPr>
+            </a:lvl8pPr>
+            <a:lvl9pPr eaLnBrk="1" hangingPunct="1">
+              <a:defRPr>
+                <a:solidFill>
+                  <a:schemeClr val="tx2"/>
+                </a:solidFill>
+              </a:defRPr>
+            </a:lvl9pPr>
+          </a:lstStyle>
+          <a:p>
+            <a:r>
+              <a:rPr lang="en-SG">
+                <a:latin typeface="Bahnschrift SemiLight (Body)"/>
+              </a:rPr>
+              <a:t>Phases Mapped to National Institute of Standards and Technology (</a:t>
+            </a:r>
+            <a:r>
+              <a:rPr lang="en-US">
+                <a:latin typeface="Bahnschrift SemiLight (Body)"/>
+              </a:rPr>
+              <a:t>NIST) Cybersecurity Framework</a:t>
+            </a:r>
+            <a:endParaRPr lang="en-SG" dirty="0">
+              <a:latin typeface="Bahnschrift SemiLight (Body)"/>
             </a:endParaRPr>
           </a:p>
         </p:txBody>
@@ -38054,6 +38229,15 @@
 </file>
 
 <file path=customXml/item1.xml><?xml version="1.0" encoding="utf-8"?>
+<?mso-contentType ?>
+<FormTemplates xmlns="http://schemas.microsoft.com/sharepoint/v3/contenttype/forms">
+  <Display>DocumentLibraryForm</Display>
+  <Edit>DocumentLibraryForm</Edit>
+  <New>DocumentLibraryForm</New>
+</FormTemplates>
+</file>
+
+<file path=customXml/item2.xml><?xml version="1.0" encoding="utf-8"?>
 <p:properties xmlns:p="http://schemas.microsoft.com/office/2006/metadata/properties" xmlns:xsi="http://www.w3.org/2001/XMLSchema-instance" xmlns:pc="http://schemas.microsoft.com/office/infopath/2007/PartnerControls">
   <documentManagement>
     <_ip_UnifiedCompliancePolicyUIAction xmlns="http://schemas.microsoft.com/sharepoint/v3" xsi:nil="true"/>
@@ -38071,15 +38255,6 @@
     <MediaServiceKeyPoints xmlns="71af3243-3dd4-4a8d-8c0d-dd76da1f02a5" xsi:nil="true"/>
   </documentManagement>
 </p:properties>
-</file>
-
-<file path=customXml/item2.xml><?xml version="1.0" encoding="utf-8"?>
-<?mso-contentType ?>
-<FormTemplates xmlns="http://schemas.microsoft.com/sharepoint/v3/contenttype/forms">
-  <Display>DocumentLibraryForm</Display>
-  <Edit>DocumentLibraryForm</Edit>
-  <New>DocumentLibraryForm</New>
-</FormTemplates>
 </file>
 
 <file path=customXml/item3.xml><?xml version="1.0" encoding="utf-8"?>
@@ -38413,6 +38588,14 @@
 </file>
 
 <file path=customXml/itemProps1.xml><?xml version="1.0" encoding="utf-8"?>
+<ds:datastoreItem xmlns:ds="http://schemas.openxmlformats.org/officeDocument/2006/customXml" ds:itemID="{0DE0AE46-2EED-447A-8B24-DFD65B70D448}">
+  <ds:schemaRefs>
+    <ds:schemaRef ds:uri="http://schemas.microsoft.com/sharepoint/v3/contenttype/forms"/>
+  </ds:schemaRefs>
+</ds:datastoreItem>
+</file>
+
+<file path=customXml/itemProps2.xml><?xml version="1.0" encoding="utf-8"?>
 <ds:datastoreItem xmlns:ds="http://schemas.openxmlformats.org/officeDocument/2006/customXml" ds:itemID="{EEA42C18-4C38-43BB-8CE3-C963EDA9CBBA}">
   <ds:schemaRefs>
     <ds:schemaRef ds:uri="http://schemas.microsoft.com/office/2006/metadata/properties"/>
@@ -38420,14 +38603,6 @@
     <ds:schemaRef ds:uri="http://schemas.microsoft.com/sharepoint/v3"/>
     <ds:schemaRef ds:uri="71af3243-3dd4-4a8d-8c0d-dd76da1f02a5"/>
     <ds:schemaRef ds:uri="230e9df3-be65-4c73-a93b-d1236ebd677e"/>
-  </ds:schemaRefs>
-</ds:datastoreItem>
-</file>
-
-<file path=customXml/itemProps2.xml><?xml version="1.0" encoding="utf-8"?>
-<ds:datastoreItem xmlns:ds="http://schemas.openxmlformats.org/officeDocument/2006/customXml" ds:itemID="{0DE0AE46-2EED-447A-8B24-DFD65B70D448}">
-  <ds:schemaRefs>
-    <ds:schemaRef ds:uri="http://schemas.microsoft.com/sharepoint/v3/contenttype/forms"/>
   </ds:schemaRefs>
 </ds:datastoreItem>
 </file>

</xml_diff>